<commit_message>
assignment 2 is added
</commit_message>
<xml_diff>
--- a/publisher and subscriber.pptx
+++ b/publisher and subscriber.pptx
@@ -12,6 +12,11 @@
     <p:sldId id="260" r:id="rId7"/>
     <p:sldId id="261" r:id="rId8"/>
     <p:sldId id="262" r:id="rId9"/>
+    <p:sldId id="263" r:id="rId10"/>
+    <p:sldId id="264" r:id="rId11"/>
+    <p:sldId id="265" r:id="rId12"/>
+    <p:sldId id="266" r:id="rId13"/>
+    <p:sldId id="267" r:id="rId14"/>
   </p:sldIdLst>
   <p:sldSz cx="10080625" cy="5670550"/>
   <p:notesSz cx="7559675" cy="10691813"/>
@@ -69,7 +74,7 @@
         <p:txBody>
           <a:bodyPr/>
           <a:p>
-            <a:fld id="{D9429D4B-1D21-499E-BCA3-14C127D87020}" type="slidenum">
+            <a:fld id="{1C5AB051-364A-4899-A604-BE252CB92A22}" type="slidenum">
               <a:t>&lt;#&gt;</a:t>
             </a:fld>
           </a:p>
@@ -257,7 +262,7 @@
         <p:txBody>
           <a:bodyPr/>
           <a:p>
-            <a:fld id="{A1EEC71C-DDD9-4628-A792-970C7821846D}" type="slidenum">
+            <a:fld id="{ABCA5885-E285-4349-84E8-C97A476EEEB8}" type="slidenum">
               <a:t>&lt;#&gt;</a:t>
             </a:fld>
           </a:p>
@@ -513,7 +518,7 @@
         <p:txBody>
           <a:bodyPr/>
           <a:p>
-            <a:fld id="{01CAB18F-0EF1-4746-850F-4A926C85FF33}" type="slidenum">
+            <a:fld id="{9922CB62-DBBE-470B-8C6F-B489985FD782}" type="slidenum">
               <a:t>&lt;#&gt;</a:t>
             </a:fld>
           </a:p>
@@ -837,7 +842,7 @@
         <p:txBody>
           <a:bodyPr/>
           <a:p>
-            <a:fld id="{35D3D869-0A4A-4A96-A4D4-878551C22706}" type="slidenum">
+            <a:fld id="{EA42BC01-7BCA-494D-9F29-5571773CC42F}" type="slidenum">
               <a:t>&lt;#&gt;</a:t>
             </a:fld>
           </a:p>
@@ -994,7 +999,7 @@
         <p:txBody>
           <a:bodyPr/>
           <a:p>
-            <a:fld id="{85F26895-389E-4767-BBA7-B1F07374FDC2}" type="slidenum">
+            <a:fld id="{5057BC00-1D54-42A5-A621-AE2FD99927AA}" type="slidenum">
               <a:t>&lt;#&gt;</a:t>
             </a:fld>
           </a:p>
@@ -1148,7 +1153,7 @@
         <p:txBody>
           <a:bodyPr/>
           <a:p>
-            <a:fld id="{BAF2E9A0-0AA9-4F15-AC3D-902FB465F12D}" type="slidenum">
+            <a:fld id="{5A64041D-C2D8-4344-8597-5D219057D335}" type="slidenum">
               <a:t>&lt;#&gt;</a:t>
             </a:fld>
           </a:p>
@@ -1336,7 +1341,7 @@
         <p:txBody>
           <a:bodyPr/>
           <a:p>
-            <a:fld id="{185DD461-DFAA-4925-B030-8CE667EEA570}" type="slidenum">
+            <a:fld id="{59C71AF5-7B2B-4E33-AB39-8A0DAEA1675F}" type="slidenum">
               <a:t>&lt;#&gt;</a:t>
             </a:fld>
           </a:p>
@@ -1456,7 +1461,7 @@
         <p:txBody>
           <a:bodyPr/>
           <a:p>
-            <a:fld id="{E72479D0-0786-41E3-80AA-8DA23F0E2D25}" type="slidenum">
+            <a:fld id="{FEA310BB-C868-410B-A47A-D54E00EEEE11}" type="slidenum">
               <a:t>&lt;#&gt;</a:t>
             </a:fld>
           </a:p>
@@ -1576,7 +1581,7 @@
         <p:txBody>
           <a:bodyPr/>
           <a:p>
-            <a:fld id="{5981A306-46CC-401F-A767-24AF2362B1E6}" type="slidenum">
+            <a:fld id="{4CCD51FD-BEB2-41A5-85C7-2B50E0BB433E}" type="slidenum">
               <a:t>&lt;#&gt;</a:t>
             </a:fld>
           </a:p>
@@ -1798,7 +1803,7 @@
         <p:txBody>
           <a:bodyPr/>
           <a:p>
-            <a:fld id="{BBD075F2-99B6-4F96-A640-C4A33B2C9AC9}" type="slidenum">
+            <a:fld id="{A41DC8AE-3E70-4F06-80F6-6BB8F2CE710E}" type="slidenum">
               <a:t>&lt;#&gt;</a:t>
             </a:fld>
           </a:p>
@@ -2020,7 +2025,7 @@
         <p:txBody>
           <a:bodyPr/>
           <a:p>
-            <a:fld id="{6972AF94-48F2-4625-AE95-CF0BEE956B69}" type="slidenum">
+            <a:fld id="{FAFDC333-B5C9-4667-92E3-DD0CE978AE21}" type="slidenum">
               <a:t>&lt;#&gt;</a:t>
             </a:fld>
           </a:p>
@@ -2242,7 +2247,7 @@
         <p:txBody>
           <a:bodyPr/>
           <a:p>
-            <a:fld id="{75618015-2C95-4972-A45A-B5DC9476D055}" type="slidenum">
+            <a:fld id="{018C8B23-C579-45E1-A409-13FD344AD2A3}" type="slidenum">
               <a:t>&lt;#&gt;</a:t>
             </a:fld>
           </a:p>
@@ -2304,7 +2309,7 @@
         <p:spPr>
           <a:xfrm>
             <a:off x="3447360" y="5165280"/>
-            <a:ext cx="3194280" cy="389880"/>
+            <a:ext cx="3193920" cy="389520"/>
           </a:xfrm>
           <a:prstGeom prst="rect">
             <a:avLst/>
@@ -2361,7 +2366,7 @@
         <p:spPr>
           <a:xfrm>
             <a:off x="7227360" y="5165280"/>
-            <a:ext cx="2347560" cy="389880"/>
+            <a:ext cx="2347200" cy="389520"/>
           </a:xfrm>
           <a:prstGeom prst="rect">
             <a:avLst/>
@@ -2393,7 +2398,7 @@
               </a:lnSpc>
               <a:buNone/>
             </a:pPr>
-            <a:fld id="{FB598C44-0496-458C-93E0-314102C747B8}" type="slidenum">
+            <a:fld id="{43F064C4-9A59-4E75-8D3C-7FBA6B142CCC}" type="slidenum">
               <a:rPr b="0" lang="en-US" sz="1400" spc="-1" strike="noStrike">
                 <a:latin typeface="Times New Roman"/>
               </a:rPr>
@@ -2418,7 +2423,7 @@
         <p:spPr>
           <a:xfrm>
             <a:off x="504000" y="5165280"/>
-            <a:ext cx="2347560" cy="389880"/>
+            <a:ext cx="2347200" cy="389520"/>
           </a:xfrm>
           <a:prstGeom prst="rect">
             <a:avLst/>
@@ -2724,7 +2729,7 @@
         <p:spPr>
           <a:xfrm>
             <a:off x="685800" y="741960"/>
-            <a:ext cx="4269240" cy="857880"/>
+            <a:ext cx="4268880" cy="857520"/>
           </a:xfrm>
           <a:prstGeom prst="rect">
             <a:avLst/>
@@ -2753,7 +2758,11 @@
             </a:pPr>
             <a:r>
               <a:rPr b="1" lang="en-US" sz="1800" spc="-1" strike="noStrike">
-                <a:latin typeface="Arial"/>
+                <a:solidFill>
+                  <a:srgbClr val="000000"/>
+                </a:solidFill>
+                <a:latin typeface="Arial"/>
+                <a:ea typeface="DejaVu Sans"/>
               </a:rPr>
               <a:t>WAP in C++ to determine force using:</a:t>
             </a:r>
@@ -2781,7 +2790,11 @@
             </a:pPr>
             <a:r>
               <a:rPr b="0" lang="en-US" sz="1800" spc="-1" strike="noStrike">
-                <a:latin typeface="Arial"/>
+                <a:solidFill>
+                  <a:srgbClr val="000000"/>
+                </a:solidFill>
+                <a:latin typeface="Arial"/>
+                <a:ea typeface="DejaVu Sans"/>
               </a:rPr>
               <a:t>Force = mass * acceleration</a:t>
             </a:r>
@@ -2800,7 +2813,7 @@
         <p:spPr>
           <a:xfrm>
             <a:off x="685800" y="2514600"/>
-            <a:ext cx="3519360" cy="857880"/>
+            <a:ext cx="3519000" cy="857520"/>
           </a:xfrm>
           <a:prstGeom prst="rect">
             <a:avLst/>
@@ -2829,7 +2842,11 @@
             </a:pPr>
             <a:r>
               <a:rPr b="1" lang="en-US" sz="1800" spc="-1" strike="noStrike">
-                <a:latin typeface="Arial"/>
+                <a:solidFill>
+                  <a:srgbClr val="000000"/>
+                </a:solidFill>
+                <a:latin typeface="Arial"/>
+                <a:ea typeface="DejaVu Sans"/>
               </a:rPr>
               <a:t>WAP in C++ to pressure using:</a:t>
             </a:r>
@@ -2857,7 +2874,11 @@
             </a:pPr>
             <a:r>
               <a:rPr b="0" lang="en-US" sz="1800" spc="-1" strike="noStrike">
-                <a:latin typeface="Arial"/>
+                <a:solidFill>
+                  <a:srgbClr val="000000"/>
+                </a:solidFill>
+                <a:latin typeface="Arial"/>
+                <a:ea typeface="DejaVu Sans"/>
               </a:rPr>
               <a:t>Pressure = Force/Area</a:t>
             </a:r>
@@ -2867,6 +2888,235 @@
           </a:p>
         </p:txBody>
       </p:sp>
+    </p:spTree>
+  </p:cSld>
+  <mc:AlternateContent>
+    <mc:Choice Requires="p14">
+      <p:transition spd="slow" p14:dur="2000"/>
+    </mc:Choice>
+    <mc:Fallback>
+      <p:transition spd="slow"/>
+    </mc:Fallback>
+  </mc:AlternateContent>
+</p:sld>
+</file>
+
+<file path=ppt/slides/slide10.xml><?xml version="1.0" encoding="utf-8"?>
+<p:sld xmlns:a="http://schemas.openxmlformats.org/drawingml/2006/main" xmlns:p="http://schemas.openxmlformats.org/presentationml/2006/main" xmlns:r="http://schemas.openxmlformats.org/officeDocument/2006/relationships" xmlns:p14="http://schemas.microsoft.com/office/powerpoint/2010/main" xmlns:p15="http://schemas.microsoft.com/office/powerpoint/2012/main" xmlns:mc="http://schemas.openxmlformats.org/markup-compatibility/2006">
+  <p:cSld>
+    <p:spTree>
+      <p:nvGrpSpPr>
+        <p:cNvPr id="1" name=""/>
+        <p:cNvGrpSpPr/>
+        <p:nvPr/>
+      </p:nvGrpSpPr>
+      <p:grpSpPr>
+        <a:xfrm>
+          <a:off x="0" y="0"/>
+          <a:ext cx="0" cy="0"/>
+          <a:chOff x="0" y="0"/>
+          <a:chExt cx="0" cy="0"/>
+        </a:xfrm>
+      </p:grpSpPr>
+      <p:pic>
+        <p:nvPicPr>
+          <p:cNvPr id="54" name="" descr=""/>
+          <p:cNvPicPr/>
+          <p:nvPr/>
+        </p:nvPicPr>
+        <p:blipFill>
+          <a:blip r:embed="rId1"/>
+          <a:stretch/>
+        </p:blipFill>
+        <p:spPr>
+          <a:xfrm>
+            <a:off x="514080" y="457200"/>
+            <a:ext cx="4515120" cy="4800600"/>
+          </a:xfrm>
+          <a:prstGeom prst="rect">
+            <a:avLst/>
+          </a:prstGeom>
+          <a:ln w="0">
+            <a:noFill/>
+          </a:ln>
+        </p:spPr>
+      </p:pic>
+      <p:pic>
+        <p:nvPicPr>
+          <p:cNvPr id="55" name="" descr=""/>
+          <p:cNvPicPr/>
+          <p:nvPr/>
+        </p:nvPicPr>
+        <p:blipFill>
+          <a:blip r:embed="rId2"/>
+          <a:stretch/>
+        </p:blipFill>
+        <p:spPr>
+          <a:xfrm>
+            <a:off x="5486400" y="457200"/>
+            <a:ext cx="4157640" cy="4800600"/>
+          </a:xfrm>
+          <a:prstGeom prst="rect">
+            <a:avLst/>
+          </a:prstGeom>
+          <a:ln w="0">
+            <a:noFill/>
+          </a:ln>
+        </p:spPr>
+      </p:pic>
+    </p:spTree>
+  </p:cSld>
+  <mc:AlternateContent>
+    <mc:Choice Requires="p14">
+      <p:transition spd="slow" p14:dur="2000"/>
+    </mc:Choice>
+    <mc:Fallback>
+      <p:transition spd="slow"/>
+    </mc:Fallback>
+  </mc:AlternateContent>
+</p:sld>
+</file>
+
+<file path=ppt/slides/slide11.xml><?xml version="1.0" encoding="utf-8"?>
+<p:sld xmlns:a="http://schemas.openxmlformats.org/drawingml/2006/main" xmlns:p="http://schemas.openxmlformats.org/presentationml/2006/main" xmlns:r="http://schemas.openxmlformats.org/officeDocument/2006/relationships" xmlns:p14="http://schemas.microsoft.com/office/powerpoint/2010/main" xmlns:p15="http://schemas.microsoft.com/office/powerpoint/2012/main" xmlns:mc="http://schemas.openxmlformats.org/markup-compatibility/2006">
+  <p:cSld>
+    <p:spTree>
+      <p:nvGrpSpPr>
+        <p:cNvPr id="1" name=""/>
+        <p:cNvGrpSpPr/>
+        <p:nvPr/>
+      </p:nvGrpSpPr>
+      <p:grpSpPr>
+        <a:xfrm>
+          <a:off x="0" y="0"/>
+          <a:ext cx="0" cy="0"/>
+          <a:chOff x="0" y="0"/>
+          <a:chExt cx="0" cy="0"/>
+        </a:xfrm>
+      </p:grpSpPr>
+      <p:pic>
+        <p:nvPicPr>
+          <p:cNvPr id="56" name="" descr=""/>
+          <p:cNvPicPr/>
+          <p:nvPr/>
+        </p:nvPicPr>
+        <p:blipFill>
+          <a:blip r:embed="rId1"/>
+          <a:stretch/>
+        </p:blipFill>
+        <p:spPr>
+          <a:xfrm>
+            <a:off x="228600" y="228600"/>
+            <a:ext cx="4572000" cy="5071320"/>
+          </a:xfrm>
+          <a:prstGeom prst="rect">
+            <a:avLst/>
+          </a:prstGeom>
+          <a:ln w="0">
+            <a:noFill/>
+          </a:ln>
+        </p:spPr>
+      </p:pic>
+      <p:pic>
+        <p:nvPicPr>
+          <p:cNvPr id="57" name="" descr=""/>
+          <p:cNvPicPr/>
+          <p:nvPr/>
+        </p:nvPicPr>
+        <p:blipFill>
+          <a:blip r:embed="rId2"/>
+          <a:stretch/>
+        </p:blipFill>
+        <p:spPr>
+          <a:xfrm>
+            <a:off x="5559120" y="44640"/>
+            <a:ext cx="3813480" cy="5441760"/>
+          </a:xfrm>
+          <a:prstGeom prst="rect">
+            <a:avLst/>
+          </a:prstGeom>
+          <a:ln w="0">
+            <a:noFill/>
+          </a:ln>
+        </p:spPr>
+      </p:pic>
+    </p:spTree>
+  </p:cSld>
+  <mc:AlternateContent>
+    <mc:Choice Requires="p14">
+      <p:transition spd="slow" p14:dur="2000"/>
+    </mc:Choice>
+    <mc:Fallback>
+      <p:transition spd="slow"/>
+    </mc:Fallback>
+  </mc:AlternateContent>
+</p:sld>
+</file>
+
+<file path=ppt/slides/slide12.xml><?xml version="1.0" encoding="utf-8"?>
+<p:sld xmlns:a="http://schemas.openxmlformats.org/drawingml/2006/main" xmlns:p="http://schemas.openxmlformats.org/presentationml/2006/main" xmlns:r="http://schemas.openxmlformats.org/officeDocument/2006/relationships" xmlns:p14="http://schemas.microsoft.com/office/powerpoint/2010/main" xmlns:p15="http://schemas.microsoft.com/office/powerpoint/2012/main" xmlns:mc="http://schemas.openxmlformats.org/markup-compatibility/2006">
+  <p:cSld>
+    <p:spTree>
+      <p:nvGrpSpPr>
+        <p:cNvPr id="1" name=""/>
+        <p:cNvGrpSpPr/>
+        <p:nvPr/>
+      </p:nvGrpSpPr>
+      <p:grpSpPr>
+        <a:xfrm>
+          <a:off x="0" y="0"/>
+          <a:ext cx="0" cy="0"/>
+          <a:chOff x="0" y="0"/>
+          <a:chExt cx="0" cy="0"/>
+        </a:xfrm>
+      </p:grpSpPr>
+      <p:pic>
+        <p:nvPicPr>
+          <p:cNvPr id="58" name="" descr=""/>
+          <p:cNvPicPr/>
+          <p:nvPr/>
+        </p:nvPicPr>
+        <p:blipFill>
+          <a:blip r:embed="rId1"/>
+          <a:srcRect l="0" t="0" r="19770" b="0"/>
+          <a:stretch/>
+        </p:blipFill>
+        <p:spPr>
+          <a:xfrm>
+            <a:off x="108000" y="788760"/>
+            <a:ext cx="4637880" cy="4047840"/>
+          </a:xfrm>
+          <a:prstGeom prst="rect">
+            <a:avLst/>
+          </a:prstGeom>
+          <a:ln w="0">
+            <a:noFill/>
+          </a:ln>
+        </p:spPr>
+      </p:pic>
+      <p:pic>
+        <p:nvPicPr>
+          <p:cNvPr id="59" name="" descr=""/>
+          <p:cNvPicPr/>
+          <p:nvPr/>
+        </p:nvPicPr>
+        <p:blipFill>
+          <a:blip r:embed="rId2"/>
+          <a:stretch/>
+        </p:blipFill>
+        <p:spPr>
+          <a:xfrm>
+            <a:off x="5715000" y="228600"/>
+            <a:ext cx="3458160" cy="5257800"/>
+          </a:xfrm>
+          <a:prstGeom prst="rect">
+            <a:avLst/>
+          </a:prstGeom>
+          <a:ln w="0">
+            <a:noFill/>
+          </a:ln>
+        </p:spPr>
+      </p:pic>
     </p:spTree>
   </p:cSld>
   <mc:AlternateContent>
@@ -2910,7 +3160,7 @@
         <p:spPr>
           <a:xfrm>
             <a:off x="2286000" y="1200600"/>
-            <a:ext cx="6114240" cy="2913840"/>
+            <a:ext cx="6113880" cy="2913480"/>
           </a:xfrm>
           <a:prstGeom prst="rect">
             <a:avLst/>
@@ -2923,13 +3173,13 @@
       <p:sp>
         <p:nvSpPr>
           <p:cNvPr id="44" name=""/>
-          <p:cNvSpPr txBox="1"/>
+          <p:cNvSpPr/>
           <p:nvPr/>
         </p:nvSpPr>
         <p:spPr>
           <a:xfrm>
             <a:off x="457200" y="457200"/>
-            <a:ext cx="6858000" cy="602280"/>
+            <a:ext cx="6857640" cy="601920"/>
           </a:xfrm>
           <a:prstGeom prst="rect">
             <a:avLst/>
@@ -2939,11 +3189,23 @@
             <a:noFill/>
           </a:ln>
         </p:spPr>
+        <p:style>
+          <a:lnRef idx="0"/>
+          <a:fillRef idx="0"/>
+          <a:effectRef idx="0"/>
+          <a:fontRef idx="minor"/>
+        </p:style>
         <p:txBody>
           <a:bodyPr lIns="90000" rIns="90000" tIns="45000" bIns="45000" anchor="t">
             <a:noAutofit/>
           </a:bodyPr>
           <a:p>
+            <a:pPr>
+              <a:lnSpc>
+                <a:spcPct val="100000"/>
+              </a:lnSpc>
+              <a:buNone/>
+            </a:pPr>
             <a:r>
               <a:rPr b="1" lang="en-US" sz="1800" spc="-1" strike="noStrike">
                 <a:latin typeface="Arial"/>
@@ -2994,13 +3256,13 @@
         </p:nvPicPr>
         <p:blipFill>
           <a:blip r:embed="rId1"/>
-          <a:srcRect l="0" t="2759" r="31112" b="3250"/>
+          <a:srcRect l="0" t="2759" r="31106" b="3250"/>
           <a:stretch/>
         </p:blipFill>
         <p:spPr>
           <a:xfrm>
             <a:off x="1298880" y="72000"/>
-            <a:ext cx="3342960" cy="5486040"/>
+            <a:ext cx="3342600" cy="5485680"/>
           </a:xfrm>
           <a:prstGeom prst="rect">
             <a:avLst/>
@@ -3023,7 +3285,7 @@
         <p:spPr>
           <a:xfrm>
             <a:off x="5224680" y="0"/>
-            <a:ext cx="4505760" cy="5670000"/>
+            <a:ext cx="4505400" cy="5669640"/>
           </a:xfrm>
           <a:prstGeom prst="rect">
             <a:avLst/>
@@ -3151,7 +3413,7 @@
         <p:spPr>
           <a:xfrm>
             <a:off x="3200400" y="20520"/>
-            <a:ext cx="4114440" cy="5622120"/>
+            <a:ext cx="4114080" cy="5621760"/>
           </a:xfrm>
           <a:prstGeom prst="rect">
             <a:avLst/>
@@ -3200,7 +3462,7 @@
         <p:spPr>
           <a:xfrm>
             <a:off x="1143000" y="914400"/>
-            <a:ext cx="5971680" cy="1848600"/>
+            <a:ext cx="5971320" cy="1848240"/>
           </a:xfrm>
           <a:prstGeom prst="rect">
             <a:avLst/>
@@ -3229,7 +3491,11 @@
             </a:pPr>
             <a:r>
               <a:rPr b="1" lang="en-US" sz="1400" spc="-1" strike="noStrike">
-                <a:latin typeface="Arial"/>
+                <a:solidFill>
+                  <a:srgbClr val="000000"/>
+                </a:solidFill>
+                <a:latin typeface="Arial"/>
+                <a:ea typeface="DejaVu Sans"/>
               </a:rPr>
               <a:t>For example:</a:t>
             </a:r>
@@ -3246,7 +3512,11 @@
             </a:pPr>
             <a:r>
               <a:rPr b="0" lang="en-US" sz="1000" spc="-1" strike="noStrike">
+                <a:solidFill>
+                  <a:srgbClr val="000000"/>
+                </a:solidFill>
                 <a:latin typeface="Courier New"/>
+                <a:ea typeface="DejaVu Sans"/>
               </a:rPr>
               <a:t>Enter the first number: 20</a:t>
             </a:r>
@@ -3263,7 +3533,11 @@
             </a:pPr>
             <a:r>
               <a:rPr b="0" lang="en-US" sz="1000" spc="-1" strike="noStrike">
+                <a:solidFill>
+                  <a:srgbClr val="000000"/>
+                </a:solidFill>
                 <a:latin typeface="Courier New"/>
+                <a:ea typeface="DejaVu Sans"/>
               </a:rPr>
               <a:t>Enter the second number: 5</a:t>
             </a:r>
@@ -3291,6 +3565,9 @@
             </a:pPr>
             <a:r>
               <a:rPr b="0" lang="en-US" sz="1000" spc="-1" strike="noStrike">
+                <a:solidFill>
+                  <a:srgbClr val="000000"/>
+                </a:solidFill>
                 <a:latin typeface="Courier New"/>
                 <a:ea typeface="Courier New"/>
               </a:rPr>
@@ -3309,6 +3586,9 @@
             </a:pPr>
             <a:r>
               <a:rPr b="0" lang="en-US" sz="1000" spc="-1" strike="noStrike">
+                <a:solidFill>
+                  <a:srgbClr val="000000"/>
+                </a:solidFill>
                 <a:latin typeface="Courier New"/>
                 <a:ea typeface="Courier New"/>
               </a:rPr>
@@ -3338,6 +3618,9 @@
             </a:pPr>
             <a:r>
               <a:rPr b="0" lang="en-US" sz="1000" spc="-1" strike="noStrike">
+                <a:solidFill>
+                  <a:srgbClr val="000000"/>
+                </a:solidFill>
                 <a:latin typeface="Courier New"/>
                 <a:ea typeface="Courier New"/>
               </a:rPr>
@@ -3367,6 +3650,9 @@
             </a:pPr>
             <a:r>
               <a:rPr b="1" lang="en-US" sz="1000" spc="-1" strike="noStrike">
+                <a:solidFill>
+                  <a:srgbClr val="000000"/>
+                </a:solidFill>
                 <a:latin typeface="Courier New"/>
                 <a:ea typeface="Courier New"/>
               </a:rPr>
@@ -3422,13 +3708,13 @@
       <p:sp>
         <p:nvSpPr>
           <p:cNvPr id="49" name=""/>
-          <p:cNvSpPr txBox="1"/>
+          <p:cNvSpPr/>
           <p:nvPr/>
         </p:nvSpPr>
         <p:spPr>
           <a:xfrm>
             <a:off x="457200" y="457200"/>
-            <a:ext cx="8686800" cy="346320"/>
+            <a:ext cx="8686440" cy="345960"/>
           </a:xfrm>
           <a:prstGeom prst="rect">
             <a:avLst/>
@@ -3438,11 +3724,23 @@
             <a:noFill/>
           </a:ln>
         </p:spPr>
+        <p:style>
+          <a:lnRef idx="0"/>
+          <a:fillRef idx="0"/>
+          <a:effectRef idx="0"/>
+          <a:fontRef idx="minor"/>
+        </p:style>
         <p:txBody>
           <a:bodyPr lIns="90000" rIns="90000" tIns="45000" bIns="45000" anchor="t">
             <a:noAutofit/>
           </a:bodyPr>
           <a:p>
+            <a:pPr>
+              <a:lnSpc>
+                <a:spcPct val="100000"/>
+              </a:lnSpc>
+              <a:buNone/>
+            </a:pPr>
             <a:r>
               <a:rPr b="1" lang="en-US" sz="1800" spc="-1" strike="noStrike">
                 <a:latin typeface="Arial"/>
@@ -3458,13 +3756,13 @@
       <p:sp>
         <p:nvSpPr>
           <p:cNvPr id="50" name=""/>
-          <p:cNvSpPr txBox="1"/>
+          <p:cNvSpPr/>
           <p:nvPr/>
         </p:nvSpPr>
         <p:spPr>
           <a:xfrm>
             <a:off x="2286000" y="1482480"/>
-            <a:ext cx="3429000" cy="3089520"/>
+            <a:ext cx="3428640" cy="3089160"/>
           </a:xfrm>
           <a:prstGeom prst="rect">
             <a:avLst/>
@@ -3474,11 +3772,23 @@
             <a:noFill/>
           </a:ln>
         </p:spPr>
+        <p:style>
+          <a:lnRef idx="0"/>
+          <a:fillRef idx="0"/>
+          <a:effectRef idx="0"/>
+          <a:fontRef idx="minor"/>
+        </p:style>
         <p:txBody>
           <a:bodyPr lIns="90000" rIns="90000" tIns="45000" bIns="45000" anchor="t">
             <a:noAutofit/>
           </a:bodyPr>
           <a:p>
+            <a:pPr>
+              <a:lnSpc>
+                <a:spcPct val="100000"/>
+              </a:lnSpc>
+              <a:buNone/>
+            </a:pPr>
             <a:r>
               <a:rPr b="0" lang="en-US" sz="1600" spc="-1" strike="noStrike">
                 <a:latin typeface="Arial"/>
@@ -3490,6 +3800,12 @@
             </a:endParaRPr>
           </a:p>
           <a:p>
+            <a:pPr>
+              <a:lnSpc>
+                <a:spcPct val="100000"/>
+              </a:lnSpc>
+              <a:buNone/>
+            </a:pPr>
             <a:r>
               <a:rPr b="0" lang="en-US" sz="1600" spc="-1" strike="noStrike">
                 <a:latin typeface="Arial"/>
@@ -3501,6 +3817,12 @@
             </a:endParaRPr>
           </a:p>
           <a:p>
+            <a:pPr>
+              <a:lnSpc>
+                <a:spcPct val="100000"/>
+              </a:lnSpc>
+              <a:buNone/>
+            </a:pPr>
             <a:r>
               <a:rPr b="0" lang="en-US" sz="1600" spc="-1" strike="noStrike">
                 <a:latin typeface="Arial"/>
@@ -3512,6 +3834,12 @@
             </a:endParaRPr>
           </a:p>
           <a:p>
+            <a:pPr>
+              <a:lnSpc>
+                <a:spcPct val="100000"/>
+              </a:lnSpc>
+              <a:buNone/>
+            </a:pPr>
             <a:r>
               <a:rPr b="0" lang="en-US" sz="1600" spc="-1" strike="noStrike">
                 <a:latin typeface="Arial"/>
@@ -3523,6 +3851,12 @@
             </a:endParaRPr>
           </a:p>
           <a:p>
+            <a:pPr>
+              <a:lnSpc>
+                <a:spcPct val="100000"/>
+              </a:lnSpc>
+              <a:buNone/>
+            </a:pPr>
             <a:r>
               <a:rPr b="0" lang="en-US" sz="1600" spc="-1" strike="noStrike">
                 <a:latin typeface="Arial"/>
@@ -3534,6 +3868,12 @@
             </a:endParaRPr>
           </a:p>
           <a:p>
+            <a:pPr>
+              <a:lnSpc>
+                <a:spcPct val="100000"/>
+              </a:lnSpc>
+              <a:buNone/>
+            </a:pPr>
             <a:r>
               <a:rPr b="0" lang="en-US" sz="1600" spc="-1" strike="noStrike">
                 <a:latin typeface="Arial"/>
@@ -3545,6 +3885,12 @@
             </a:endParaRPr>
           </a:p>
           <a:p>
+            <a:pPr>
+              <a:lnSpc>
+                <a:spcPct val="100000"/>
+              </a:lnSpc>
+              <a:buNone/>
+            </a:pPr>
             <a:r>
               <a:rPr b="0" lang="en-US" sz="1600" spc="-1" strike="noStrike">
                 <a:latin typeface="Arial"/>
@@ -3556,6 +3902,12 @@
             </a:endParaRPr>
           </a:p>
           <a:p>
+            <a:pPr>
+              <a:lnSpc>
+                <a:spcPct val="100000"/>
+              </a:lnSpc>
+              <a:buNone/>
+            </a:pPr>
             <a:r>
               <a:rPr b="0" lang="en-US" sz="1600" spc="-1" strike="noStrike">
                 <a:latin typeface="Arial"/>
@@ -3567,6 +3919,12 @@
             </a:endParaRPr>
           </a:p>
           <a:p>
+            <a:pPr>
+              <a:lnSpc>
+                <a:spcPct val="100000"/>
+              </a:lnSpc>
+              <a:buNone/>
+            </a:pPr>
             <a:r>
               <a:rPr b="0" lang="en-US" sz="1600" spc="-1" strike="noStrike">
                 <a:latin typeface="Arial"/>
@@ -3578,6 +3936,12 @@
             </a:endParaRPr>
           </a:p>
           <a:p>
+            <a:pPr>
+              <a:lnSpc>
+                <a:spcPct val="100000"/>
+              </a:lnSpc>
+              <a:buNone/>
+            </a:pPr>
             <a:r>
               <a:rPr b="0" lang="en-US" sz="1600" spc="-1" strike="noStrike">
                 <a:latin typeface="Arial"/>
@@ -3628,13 +3992,13 @@
         </p:nvPicPr>
         <p:blipFill>
           <a:blip r:embed="rId1"/>
-          <a:srcRect l="0" t="0" r="37019" b="0"/>
+          <a:srcRect l="0" t="0" r="37015" b="0"/>
           <a:stretch/>
         </p:blipFill>
         <p:spPr>
           <a:xfrm>
             <a:off x="6076440" y="0"/>
-            <a:ext cx="3499560" cy="5670360"/>
+            <a:ext cx="3499200" cy="5670000"/>
           </a:xfrm>
           <a:prstGeom prst="rect">
             <a:avLst/>
@@ -3657,7 +4021,7 @@
         <p:spPr>
           <a:xfrm>
             <a:off x="311400" y="72720"/>
-            <a:ext cx="5378400" cy="5487840"/>
+            <a:ext cx="5378040" cy="5487480"/>
           </a:xfrm>
           <a:prstGeom prst="rect">
             <a:avLst/>
@@ -3667,6 +4031,544 @@
           </a:ln>
         </p:spPr>
       </p:pic>
+    </p:spTree>
+  </p:cSld>
+  <mc:AlternateContent>
+    <mc:Choice Requires="p14">
+      <p:transition spd="slow" p14:dur="2000"/>
+    </mc:Choice>
+    <mc:Fallback>
+      <p:transition spd="slow"/>
+    </mc:Fallback>
+  </mc:AlternateContent>
+</p:sld>
+</file>
+
+<file path=ppt/slides/slide8.xml><?xml version="1.0" encoding="utf-8"?>
+<p:sld xmlns:a="http://schemas.openxmlformats.org/drawingml/2006/main" xmlns:p="http://schemas.openxmlformats.org/presentationml/2006/main" xmlns:r="http://schemas.openxmlformats.org/officeDocument/2006/relationships" xmlns:p14="http://schemas.microsoft.com/office/powerpoint/2010/main" xmlns:p15="http://schemas.microsoft.com/office/powerpoint/2012/main" xmlns:mc="http://schemas.openxmlformats.org/markup-compatibility/2006">
+  <p:cSld>
+    <p:spTree>
+      <p:nvGrpSpPr>
+        <p:cNvPr id="1" name=""/>
+        <p:cNvGrpSpPr/>
+        <p:nvPr/>
+      </p:nvGrpSpPr>
+      <p:grpSpPr>
+        <a:xfrm>
+          <a:off x="0" y="0"/>
+          <a:ext cx="0" cy="0"/>
+          <a:chOff x="0" y="0"/>
+          <a:chExt cx="0" cy="0"/>
+        </a:xfrm>
+      </p:grpSpPr>
+      <p:sp>
+        <p:nvSpPr>
+          <p:cNvPr id="53" name=""/>
+          <p:cNvSpPr txBox="1"/>
+          <p:nvPr/>
+        </p:nvSpPr>
+        <p:spPr>
+          <a:xfrm>
+            <a:off x="645480" y="228600"/>
+            <a:ext cx="9184320" cy="5360760"/>
+          </a:xfrm>
+          <a:prstGeom prst="rect">
+            <a:avLst/>
+          </a:prstGeom>
+          <a:noFill/>
+          <a:ln w="0">
+            <a:noFill/>
+          </a:ln>
+        </p:spPr>
+        <p:txBody>
+          <a:bodyPr lIns="90000" rIns="90000" tIns="45000" bIns="45000" anchor="t">
+            <a:noAutofit/>
+          </a:bodyPr>
+          <a:p>
+            <a:r>
+              <a:rPr b="1" lang="en-US" sz="1200" spc="-1" strike="noStrike">
+                <a:latin typeface="Arial"/>
+              </a:rPr>
+              <a:t>Develop a ROS 2 Python program to calculate the acceleration, force, and torque of a moving robot using publisher and subscriber nodes.</a:t>
+            </a:r>
+            <a:endParaRPr b="0" lang="en-US" sz="1200" spc="-1" strike="noStrike">
+              <a:latin typeface="Arial"/>
+            </a:endParaRPr>
+          </a:p>
+          <a:p>
+            <a:endParaRPr b="0" lang="en-US" sz="1200" spc="-1" strike="noStrike">
+              <a:latin typeface="Arial"/>
+            </a:endParaRPr>
+          </a:p>
+          <a:p>
+            <a:r>
+              <a:rPr b="0" lang="en-US" sz="1200" spc="-1" strike="noStrike">
+                <a:latin typeface="Arial"/>
+              </a:rPr>
+              <a:t>The system should contain three nodes:</a:t>
+            </a:r>
+            <a:endParaRPr b="0" lang="en-US" sz="1200" spc="-1" strike="noStrike">
+              <a:latin typeface="Arial"/>
+            </a:endParaRPr>
+          </a:p>
+          <a:p>
+            <a:endParaRPr b="0" lang="en-US" sz="1200" spc="-1" strike="noStrike">
+              <a:latin typeface="Arial"/>
+            </a:endParaRPr>
+          </a:p>
+          <a:p>
+            <a:pPr marL="216000" indent="-216000">
+              <a:spcBef>
+                <a:spcPts val="215"/>
+              </a:spcBef>
+              <a:spcAft>
+                <a:spcPts val="289"/>
+              </a:spcAft>
+              <a:buClr>
+                <a:srgbClr val="000000"/>
+              </a:buClr>
+              <a:buFont typeface="StarSymbol"/>
+              <a:buAutoNum type="arabicPeriod"/>
+            </a:pPr>
+            <a:r>
+              <a:rPr b="1" lang="en-US" sz="1200" spc="-1" strike="noStrike">
+                <a:latin typeface="Arial"/>
+              </a:rPr>
+              <a:t>Acceleration Publisher </a:t>
+            </a:r>
+            <a:endParaRPr b="0" lang="en-US" sz="1200" spc="-1" strike="noStrike">
+              <a:latin typeface="Arial"/>
+            </a:endParaRPr>
+          </a:p>
+          <a:p>
+            <a:pPr lvl="1" marL="432000" indent="-216000">
+              <a:spcBef>
+                <a:spcPts val="215"/>
+              </a:spcBef>
+              <a:spcAft>
+                <a:spcPts val="289"/>
+              </a:spcAft>
+              <a:buClr>
+                <a:srgbClr val="000000"/>
+              </a:buClr>
+              <a:buSzPct val="45000"/>
+              <a:buFont typeface="Wingdings" charset="2"/>
+              <a:buChar char=""/>
+            </a:pPr>
+            <a:r>
+              <a:rPr b="0" lang="en-US" sz="1200" spc="-1" strike="noStrike">
+                <a:latin typeface="Arial"/>
+              </a:rPr>
+              <a:t>Take initial velocity u, final velocity v, and time t. </a:t>
+            </a:r>
+            <a:endParaRPr b="0" lang="en-US" sz="1200" spc="-1" strike="noStrike">
+              <a:latin typeface="Arial"/>
+            </a:endParaRPr>
+          </a:p>
+          <a:p>
+            <a:pPr lvl="1" marL="432000" indent="-216000">
+              <a:spcBef>
+                <a:spcPts val="215"/>
+              </a:spcBef>
+              <a:spcAft>
+                <a:spcPts val="289"/>
+              </a:spcAft>
+              <a:buClr>
+                <a:srgbClr val="000000"/>
+              </a:buClr>
+              <a:buSzPct val="45000"/>
+              <a:buFont typeface="Wingdings" charset="2"/>
+              <a:buChar char=""/>
+            </a:pPr>
+            <a:r>
+              <a:rPr b="0" lang="en-US" sz="1200" spc="-1" strike="noStrike">
+                <a:latin typeface="Arial"/>
+              </a:rPr>
+              <a:t>Calculate acceleration using:</a:t>
+            </a:r>
+            <a:endParaRPr b="0" lang="en-US" sz="1200" spc="-1" strike="noStrike">
+              <a:latin typeface="Arial"/>
+            </a:endParaRPr>
+          </a:p>
+          <a:p>
+            <a:r>
+              <a:rPr b="0" lang="en-US" sz="1200" spc="-1" strike="noStrike">
+                <a:latin typeface="Arial"/>
+              </a:rPr>
+              <a:t>	</a:t>
+            </a:r>
+            <a:r>
+              <a:rPr b="0" lang="en-US" sz="1200" spc="-1" strike="noStrike">
+                <a:latin typeface="Arial"/>
+              </a:rPr>
+              <a:t>	</a:t>
+            </a:r>
+            <a:r>
+              <a:rPr b="0" lang="en-US" sz="1200" spc="-1" strike="noStrike">
+                <a:latin typeface="Arial"/>
+              </a:rPr>
+              <a:t>a = (v - u) / t </a:t>
+            </a:r>
+            <a:endParaRPr b="0" lang="en-US" sz="1200" spc="-1" strike="noStrike">
+              <a:latin typeface="Arial"/>
+            </a:endParaRPr>
+          </a:p>
+          <a:p>
+            <a:pPr lvl="1" marL="432000" indent="-216000">
+              <a:spcBef>
+                <a:spcPts val="215"/>
+              </a:spcBef>
+              <a:spcAft>
+                <a:spcPts val="289"/>
+              </a:spcAft>
+              <a:buClr>
+                <a:srgbClr val="000000"/>
+              </a:buClr>
+              <a:buSzPct val="45000"/>
+              <a:buFont typeface="Wingdings" charset="2"/>
+              <a:buChar char=""/>
+            </a:pPr>
+            <a:r>
+              <a:rPr b="0" lang="en-US" sz="1200" spc="-1" strike="noStrike">
+                <a:latin typeface="Arial"/>
+              </a:rPr>
+              <a:t>Publish the calculated acceleration on the /acceleration topic. </a:t>
+            </a:r>
+            <a:endParaRPr b="0" lang="en-US" sz="1200" spc="-1" strike="noStrike">
+              <a:latin typeface="Arial"/>
+            </a:endParaRPr>
+          </a:p>
+          <a:p>
+            <a:pPr marL="216000" indent="-216000">
+              <a:spcBef>
+                <a:spcPts val="215"/>
+              </a:spcBef>
+              <a:spcAft>
+                <a:spcPts val="289"/>
+              </a:spcAft>
+              <a:buClr>
+                <a:srgbClr val="000000"/>
+              </a:buClr>
+              <a:buFont typeface="StarSymbol"/>
+              <a:buAutoNum type="arabicPeriod" startAt="2"/>
+            </a:pPr>
+            <a:r>
+              <a:rPr b="1" lang="en-US" sz="1200" spc="-1" strike="noStrike">
+                <a:latin typeface="Arial"/>
+              </a:rPr>
+              <a:t>Force Subscriber </a:t>
+            </a:r>
+            <a:endParaRPr b="0" lang="en-US" sz="1200" spc="-1" strike="noStrike">
+              <a:latin typeface="Arial"/>
+            </a:endParaRPr>
+          </a:p>
+          <a:p>
+            <a:pPr lvl="1" marL="432000" indent="-216000">
+              <a:spcBef>
+                <a:spcPts val="215"/>
+              </a:spcBef>
+              <a:spcAft>
+                <a:spcPts val="289"/>
+              </a:spcAft>
+              <a:buClr>
+                <a:srgbClr val="000000"/>
+              </a:buClr>
+              <a:buSzPct val="45000"/>
+              <a:buFont typeface="Wingdings" charset="2"/>
+              <a:buChar char=""/>
+            </a:pPr>
+            <a:r>
+              <a:rPr b="0" lang="en-US" sz="1200" spc="-1" strike="noStrike">
+                <a:latin typeface="Arial"/>
+              </a:rPr>
+              <a:t>Subscribe to /acceleration. </a:t>
+            </a:r>
+            <a:endParaRPr b="0" lang="en-US" sz="1200" spc="-1" strike="noStrike">
+              <a:latin typeface="Arial"/>
+            </a:endParaRPr>
+          </a:p>
+          <a:p>
+            <a:pPr lvl="1" marL="432000" indent="-216000">
+              <a:spcBef>
+                <a:spcPts val="215"/>
+              </a:spcBef>
+              <a:spcAft>
+                <a:spcPts val="289"/>
+              </a:spcAft>
+              <a:buClr>
+                <a:srgbClr val="000000"/>
+              </a:buClr>
+              <a:buSzPct val="45000"/>
+              <a:buFont typeface="Wingdings" charset="2"/>
+              <a:buChar char=""/>
+            </a:pPr>
+            <a:r>
+              <a:rPr b="0" lang="en-US" sz="1200" spc="-1" strike="noStrike">
+                <a:latin typeface="Arial"/>
+              </a:rPr>
+              <a:t>Assume a given robot mass m. </a:t>
+            </a:r>
+            <a:endParaRPr b="0" lang="en-US" sz="1200" spc="-1" strike="noStrike">
+              <a:latin typeface="Arial"/>
+            </a:endParaRPr>
+          </a:p>
+          <a:p>
+            <a:pPr lvl="1" marL="432000" indent="-216000">
+              <a:spcBef>
+                <a:spcPts val="215"/>
+              </a:spcBef>
+              <a:spcAft>
+                <a:spcPts val="289"/>
+              </a:spcAft>
+              <a:buClr>
+                <a:srgbClr val="000000"/>
+              </a:buClr>
+              <a:buSzPct val="45000"/>
+              <a:buFont typeface="Wingdings" charset="2"/>
+              <a:buChar char=""/>
+            </a:pPr>
+            <a:r>
+              <a:rPr b="0" lang="en-US" sz="1200" spc="-1" strike="noStrike">
+                <a:latin typeface="Arial"/>
+              </a:rPr>
+              <a:t>Calculate force using:</a:t>
+            </a:r>
+            <a:endParaRPr b="0" lang="en-US" sz="1200" spc="-1" strike="noStrike">
+              <a:latin typeface="Arial"/>
+            </a:endParaRPr>
+          </a:p>
+          <a:p>
+            <a:r>
+              <a:rPr b="0" lang="en-US" sz="1200" spc="-1" strike="noStrike">
+                <a:latin typeface="Arial"/>
+              </a:rPr>
+              <a:t>	</a:t>
+            </a:r>
+            <a:r>
+              <a:rPr b="0" lang="en-US" sz="1200" spc="-1" strike="noStrike">
+                <a:latin typeface="Arial"/>
+              </a:rPr>
+              <a:t>	</a:t>
+            </a:r>
+            <a:r>
+              <a:rPr b="0" lang="en-US" sz="1200" spc="-1" strike="noStrike">
+                <a:latin typeface="Arial"/>
+              </a:rPr>
+              <a:t>F = ma </a:t>
+            </a:r>
+            <a:endParaRPr b="0" lang="en-US" sz="1200" spc="-1" strike="noStrike">
+              <a:latin typeface="Arial"/>
+            </a:endParaRPr>
+          </a:p>
+          <a:p>
+            <a:pPr lvl="1" marL="432000" indent="-216000">
+              <a:spcBef>
+                <a:spcPts val="215"/>
+              </a:spcBef>
+              <a:spcAft>
+                <a:spcPts val="289"/>
+              </a:spcAft>
+              <a:buClr>
+                <a:srgbClr val="000000"/>
+              </a:buClr>
+              <a:buSzPct val="45000"/>
+              <a:buFont typeface="Wingdings" charset="2"/>
+              <a:buChar char=""/>
+            </a:pPr>
+            <a:r>
+              <a:rPr b="0" lang="en-US" sz="1200" spc="-1" strike="noStrike">
+                <a:latin typeface="Arial"/>
+              </a:rPr>
+              <a:t>Publish the calculated force on the /force topic. </a:t>
+            </a:r>
+            <a:endParaRPr b="0" lang="en-US" sz="1200" spc="-1" strike="noStrike">
+              <a:latin typeface="Arial"/>
+            </a:endParaRPr>
+          </a:p>
+          <a:p>
+            <a:pPr marL="216000" indent="-216000">
+              <a:spcBef>
+                <a:spcPts val="215"/>
+              </a:spcBef>
+              <a:spcAft>
+                <a:spcPts val="289"/>
+              </a:spcAft>
+              <a:buClr>
+                <a:srgbClr val="000000"/>
+              </a:buClr>
+              <a:buFont typeface="StarSymbol"/>
+              <a:buAutoNum type="arabicPeriod" startAt="3"/>
+            </a:pPr>
+            <a:r>
+              <a:rPr b="1" lang="en-US" sz="1200" spc="-1" strike="noStrike">
+                <a:latin typeface="Arial"/>
+              </a:rPr>
+              <a:t>Torque Subscriber </a:t>
+            </a:r>
+            <a:endParaRPr b="0" lang="en-US" sz="1200" spc="-1" strike="noStrike">
+              <a:latin typeface="Arial"/>
+            </a:endParaRPr>
+          </a:p>
+          <a:p>
+            <a:pPr lvl="1" marL="432000" indent="-216000">
+              <a:spcBef>
+                <a:spcPts val="215"/>
+              </a:spcBef>
+              <a:spcAft>
+                <a:spcPts val="289"/>
+              </a:spcAft>
+              <a:buClr>
+                <a:srgbClr val="000000"/>
+              </a:buClr>
+              <a:buSzPct val="45000"/>
+              <a:buFont typeface="Wingdings" charset="2"/>
+              <a:buChar char=""/>
+            </a:pPr>
+            <a:r>
+              <a:rPr b="0" lang="en-US" sz="1200" spc="-1" strike="noStrike">
+                <a:latin typeface="Arial"/>
+              </a:rPr>
+              <a:t>Subscribe to /force. </a:t>
+            </a:r>
+            <a:endParaRPr b="0" lang="en-US" sz="1200" spc="-1" strike="noStrike">
+              <a:latin typeface="Arial"/>
+            </a:endParaRPr>
+          </a:p>
+          <a:p>
+            <a:pPr lvl="1" marL="432000" indent="-216000">
+              <a:spcBef>
+                <a:spcPts val="215"/>
+              </a:spcBef>
+              <a:spcAft>
+                <a:spcPts val="289"/>
+              </a:spcAft>
+              <a:buClr>
+                <a:srgbClr val="000000"/>
+              </a:buClr>
+              <a:buSzPct val="45000"/>
+              <a:buFont typeface="Wingdings" charset="2"/>
+              <a:buChar char=""/>
+            </a:pPr>
+            <a:r>
+              <a:rPr b="0" lang="en-US" sz="1200" spc="-1" strike="noStrike">
+                <a:latin typeface="Arial"/>
+              </a:rPr>
+              <a:t>Assume a given wheel radius r. </a:t>
+            </a:r>
+            <a:endParaRPr b="0" lang="en-US" sz="1200" spc="-1" strike="noStrike">
+              <a:latin typeface="Arial"/>
+            </a:endParaRPr>
+          </a:p>
+          <a:p>
+            <a:pPr lvl="1" marL="432000" indent="-216000">
+              <a:spcBef>
+                <a:spcPts val="215"/>
+              </a:spcBef>
+              <a:spcAft>
+                <a:spcPts val="289"/>
+              </a:spcAft>
+              <a:buClr>
+                <a:srgbClr val="000000"/>
+              </a:buClr>
+              <a:buSzPct val="45000"/>
+              <a:buFont typeface="Wingdings" charset="2"/>
+              <a:buChar char=""/>
+            </a:pPr>
+            <a:r>
+              <a:rPr b="0" lang="en-US" sz="1200" spc="-1" strike="noStrike">
+                <a:latin typeface="Arial"/>
+              </a:rPr>
+              <a:t>Calculate wheel torque using:</a:t>
+            </a:r>
+            <a:endParaRPr b="0" lang="en-US" sz="1200" spc="-1" strike="noStrike">
+              <a:latin typeface="Arial"/>
+            </a:endParaRPr>
+          </a:p>
+          <a:p>
+            <a:r>
+              <a:rPr b="0" lang="en-US" sz="1200" spc="-1" strike="noStrike">
+                <a:latin typeface="Arial"/>
+              </a:rPr>
+              <a:t>	</a:t>
+            </a:r>
+            <a:r>
+              <a:rPr b="0" lang="en-US" sz="1200" spc="-1" strike="noStrike">
+                <a:latin typeface="Arial"/>
+              </a:rPr>
+              <a:t>	</a:t>
+            </a:r>
+            <a:r>
+              <a:rPr b="0" lang="en-US" sz="1200" spc="-1" strike="noStrike">
+                <a:latin typeface="Arial"/>
+              </a:rPr>
+              <a:t>Torque = Fr </a:t>
+            </a:r>
+            <a:endParaRPr b="0" lang="en-US" sz="1200" spc="-1" strike="noStrike">
+              <a:latin typeface="Arial"/>
+            </a:endParaRPr>
+          </a:p>
+          <a:p>
+            <a:pPr lvl="1" marL="432000" indent="-216000">
+              <a:spcBef>
+                <a:spcPts val="215"/>
+              </a:spcBef>
+              <a:spcAft>
+                <a:spcPts val="289"/>
+              </a:spcAft>
+              <a:buClr>
+                <a:srgbClr val="000000"/>
+              </a:buClr>
+              <a:buSzPct val="45000"/>
+              <a:buFont typeface="Wingdings" charset="2"/>
+              <a:buChar char=""/>
+            </a:pPr>
+            <a:r>
+              <a:rPr b="0" lang="en-US" sz="1200" spc="-1" strike="noStrike">
+                <a:latin typeface="Arial"/>
+              </a:rPr>
+              <a:t>Display the calculated torque in Nm.</a:t>
+            </a:r>
+            <a:endParaRPr b="0" lang="en-US" sz="1200" spc="-1" strike="noStrike">
+              <a:latin typeface="Arial"/>
+            </a:endParaRPr>
+          </a:p>
+          <a:p>
+            <a:endParaRPr b="0" lang="en-US" sz="1200" spc="-1" strike="noStrike">
+              <a:latin typeface="Arial"/>
+            </a:endParaRPr>
+          </a:p>
+        </p:txBody>
+      </p:sp>
+    </p:spTree>
+  </p:cSld>
+  <mc:AlternateContent>
+    <mc:Choice Requires="p14">
+      <p:transition spd="slow" p14:dur="2000"/>
+    </mc:Choice>
+    <mc:Fallback>
+      <p:transition spd="slow"/>
+    </mc:Fallback>
+  </mc:AlternateContent>
+</p:sld>
+</file>
+
+<file path=ppt/slides/slide9.xml><?xml version="1.0" encoding="utf-8"?>
+<p:sld xmlns:a="http://schemas.openxmlformats.org/drawingml/2006/main" xmlns:p="http://schemas.openxmlformats.org/presentationml/2006/main" xmlns:r="http://schemas.openxmlformats.org/officeDocument/2006/relationships" xmlns:p14="http://schemas.microsoft.com/office/powerpoint/2010/main" xmlns:p15="http://schemas.microsoft.com/office/powerpoint/2012/main" xmlns:mc="http://schemas.openxmlformats.org/markup-compatibility/2006">
+  <p:cSld>
+    <p:spTree>
+      <p:nvGrpSpPr>
+        <p:cNvPr id="1" name=""/>
+        <p:cNvGrpSpPr/>
+        <p:nvPr/>
+      </p:nvGrpSpPr>
+      <p:grpSpPr>
+        <a:xfrm>
+          <a:off x="0" y="0"/>
+          <a:ext cx="0" cy="0"/>
+          <a:chOff x="0" y="0"/>
+          <a:chExt cx="0" cy="0"/>
+        </a:xfrm>
+      </p:grpSpPr>
     </p:spTree>
   </p:cSld>
   <mc:AlternateContent>

</xml_diff>